<commit_message>
Connect Gemini AI to presentation preview
</commit_message>
<xml_diff>
--- a/generated_ppt/AI_Generated_Presentation.pptx
+++ b/generated_ppt/AI_Generated_Presentation.pptx
@@ -11,7 +11,6 @@
     <p:sldId id="259" r:id="rId10"/>
     <p:sldId id="260" r:id="rId11"/>
     <p:sldId id="261" r:id="rId12"/>
-    <p:sldId id="262" r:id="rId13"/>
   </p:sldIdLst>
   <p:sldSz cx="9144000" cy="6858000" type="screen4x3"/>
   <p:notesSz cx="6858000" cy="9144000"/>
@@ -3117,7 +3116,7 @@
             <a:avLst/>
           </a:prstGeom>
           <a:solidFill>
-            <a:srgbClr val="EA580C"/>
+            <a:srgbClr val="4F46E5"/>
           </a:solidFill>
           <a:ln>
             <a:noFill/>
@@ -3175,7 +3174,7 @@
               </a:defRPr>
             </a:pPr>
             <a:r>
-              <a:t>Introduction to Gesture Control</a:t>
+              <a:t>Introduction</a:t>
             </a:r>
           </a:p>
         </p:txBody>
@@ -3214,7 +3213,7 @@
               </a:defRPr>
             </a:pPr>
             <a:r>
-              <a:t>• Enables human-computer interaction without physical devices</a:t>
+              <a:t>• Overview of modern food delivery platforms</a:t>
             </a:r>
           </a:p>
           <a:p>
@@ -3229,7 +3228,7 @@
               </a:defRPr>
             </a:pPr>
             <a:r>
-              <a:t>• Translates hand and body movements into digital commands</a:t>
+              <a:t>• Connecting customers with local restaurants</a:t>
             </a:r>
           </a:p>
           <a:p>
@@ -3244,22 +3243,7 @@
               </a:defRPr>
             </a:pPr>
             <a:r>
-              <a:t>• Utilizes advanced sensors and computer vision technologies</a:t>
-            </a:r>
-          </a:p>
-          <a:p>
-            <a:pPr>
-              <a:spcAft>
-                <a:spcPts val="1200"/>
-              </a:spcAft>
-              <a:defRPr sz="2000">
-                <a:solidFill>
-                  <a:srgbClr val="0F172A"/>
-                </a:solidFill>
-              </a:defRPr>
-            </a:pPr>
-            <a:r>
-              <a:t>• Replaces traditional input tools like mice and keyboards</a:t>
+              <a:t>• Seamless ordering and fast fulfillment</a:t>
             </a:r>
           </a:p>
         </p:txBody>
@@ -3340,7 +3324,7 @@
             <a:avLst/>
           </a:prstGeom>
           <a:solidFill>
-            <a:srgbClr val="EA580C"/>
+            <a:srgbClr val="4F46E5"/>
           </a:solidFill>
           <a:ln>
             <a:noFill/>
@@ -3398,7 +3382,7 @@
               </a:defRPr>
             </a:pPr>
             <a:r>
-              <a:t>Core Technologies</a:t>
+              <a:t>Key Stakeholders</a:t>
             </a:r>
           </a:p>
         </p:txBody>
@@ -3437,7 +3421,7 @@
               </a:defRPr>
             </a:pPr>
             <a:r>
-              <a:t>• Computer vision for real-time visual tracking</a:t>
+              <a:t>• Customers seeking convenient meal options</a:t>
             </a:r>
           </a:p>
           <a:p>
@@ -3452,7 +3436,7 @@
               </a:defRPr>
             </a:pPr>
             <a:r>
-              <a:t>• Infrared sensors for depth and distance measurement</a:t>
+              <a:t>• Restaurants looking to increase sales and reach</a:t>
             </a:r>
           </a:p>
           <a:p>
@@ -3467,22 +3451,7 @@
               </a:defRPr>
             </a:pPr>
             <a:r>
-              <a:t>• Accelerometers and gyroscopes for motion sensing</a:t>
-            </a:r>
-          </a:p>
-          <a:p>
-            <a:pPr>
-              <a:spcAft>
-                <a:spcPts val="1200"/>
-              </a:spcAft>
-              <a:defRPr sz="2000">
-                <a:solidFill>
-                  <a:srgbClr val="0F172A"/>
-                </a:solidFill>
-              </a:defRPr>
-            </a:pPr>
-            <a:r>
-              <a:t>• Machine learning algorithms for pattern recognition</a:t>
+              <a:t>• Delivery drivers providing logistics support</a:t>
             </a:r>
           </a:p>
         </p:txBody>
@@ -3563,7 +3532,7 @@
             <a:avLst/>
           </a:prstGeom>
           <a:solidFill>
-            <a:srgbClr val="EA580C"/>
+            <a:srgbClr val="4F46E5"/>
           </a:solidFill>
           <a:ln>
             <a:noFill/>
@@ -3621,7 +3590,7 @@
               </a:defRPr>
             </a:pPr>
             <a:r>
-              <a:t>Key Applications</a:t>
+              <a:t>Customer App Features</a:t>
             </a:r>
           </a:p>
         </p:txBody>
@@ -3660,7 +3629,7 @@
               </a:defRPr>
             </a:pPr>
             <a:r>
-              <a:t>• Smart home automation and appliance control</a:t>
+              <a:t>• User-friendly interface and search filters</a:t>
             </a:r>
           </a:p>
           <a:p>
@@ -3675,7 +3644,7 @@
               </a:defRPr>
             </a:pPr>
             <a:r>
-              <a:t>• Automotive interfaces for safer driving</a:t>
+              <a:t>• Real-time order tracking via GPS</a:t>
             </a:r>
           </a:p>
           <a:p>
@@ -3690,7 +3659,7 @@
               </a:defRPr>
             </a:pPr>
             <a:r>
-              <a:t>• Healthcare systems for touchless device operation</a:t>
+              <a:t>• Secure digital payment integration</a:t>
             </a:r>
           </a:p>
           <a:p>
@@ -3705,7 +3674,7 @@
               </a:defRPr>
             </a:pPr>
             <a:r>
-              <a:t>• Immersive gaming and virtual reality experiences</a:t>
+              <a:t>• Rating and review system for restaurants</a:t>
             </a:r>
           </a:p>
         </p:txBody>
@@ -3786,7 +3755,7 @@
             <a:avLst/>
           </a:prstGeom>
           <a:solidFill>
-            <a:srgbClr val="EA580C"/>
+            <a:srgbClr val="4F46E5"/>
           </a:solidFill>
           <a:ln>
             <a:noFill/>
@@ -3844,7 +3813,7 @@
               </a:defRPr>
             </a:pPr>
             <a:r>
-              <a:t>Advantages of the System</a:t>
+              <a:t>Restaurant Portal</a:t>
             </a:r>
           </a:p>
         </p:txBody>
@@ -3883,7 +3852,7 @@
               </a:defRPr>
             </a:pPr>
             <a:r>
-              <a:t>• Provides a highly intuitive user experience</a:t>
+              <a:t>• Dashboard for managing incoming orders</a:t>
             </a:r>
           </a:p>
           <a:p>
@@ -3898,7 +3867,7 @@
               </a:defRPr>
             </a:pPr>
             <a:r>
-              <a:t>• Improves hygiene by eliminating physical touch</a:t>
+              <a:t>• Menu and pricing update capabilities</a:t>
             </a:r>
           </a:p>
           <a:p>
@@ -3913,7 +3882,7 @@
               </a:defRPr>
             </a:pPr>
             <a:r>
-              <a:t>• Allows for natural and fluid movement controls</a:t>
+              <a:t>• Analytics and sales performance reports</a:t>
             </a:r>
           </a:p>
           <a:p>
@@ -3928,7 +3897,7 @@
               </a:defRPr>
             </a:pPr>
             <a:r>
-              <a:t>• Enhances accessibility for users with disabilities</a:t>
+              <a:t>• Direct communication with customers and drivers</a:t>
             </a:r>
           </a:p>
         </p:txBody>
@@ -4009,7 +3978,7 @@
             <a:avLst/>
           </a:prstGeom>
           <a:solidFill>
-            <a:srgbClr val="EA580C"/>
+            <a:srgbClr val="4F46E5"/>
           </a:solidFill>
           <a:ln>
             <a:noFill/>
@@ -4067,7 +4036,7 @@
               </a:defRPr>
             </a:pPr>
             <a:r>
-              <a:t>Current Challenges</a:t>
+              <a:t>Delivery Logistics</a:t>
             </a:r>
           </a:p>
         </p:txBody>
@@ -4106,7 +4075,7 @@
               </a:defRPr>
             </a:pPr>
             <a:r>
-              <a:t>• High sensitivity to varying lighting conditions</a:t>
+              <a:t>• Automated order dispatch to nearby drivers</a:t>
             </a:r>
           </a:p>
           <a:p>
@@ -4121,7 +4090,7 @@
               </a:defRPr>
             </a:pPr>
             <a:r>
-              <a:t>• Difficulty in filtering out accidental movements</a:t>
+              <a:t>• Optimized routing for faster delivery times</a:t>
             </a:r>
           </a:p>
           <a:p>
@@ -4136,7 +4105,7 @@
               </a:defRPr>
             </a:pPr>
             <a:r>
-              <a:t>• Requires significant processing power for accuracy</a:t>
+              <a:t>• Driver earnings and trip history tracking</a:t>
             </a:r>
           </a:p>
           <a:p>
@@ -4151,7 +4120,7 @@
               </a:defRPr>
             </a:pPr>
             <a:r>
-              <a:t>• Lack of universal standardization across platforms</a:t>
+              <a:t>• Support for contactless delivery options</a:t>
             </a:r>
           </a:p>
         </p:txBody>
@@ -4232,7 +4201,7 @@
             <a:avLst/>
           </a:prstGeom>
           <a:solidFill>
-            <a:srgbClr val="EA580C"/>
+            <a:srgbClr val="4F46E5"/>
           </a:solidFill>
           <a:ln>
             <a:noFill/>
@@ -4290,7 +4259,7 @@
               </a:defRPr>
             </a:pPr>
             <a:r>
-              <a:t>Future Trends</a:t>
+              <a:t>Benefits and Advantages</a:t>
             </a:r>
           </a:p>
         </p:txBody>
@@ -4329,7 +4298,7 @@
               </a:defRPr>
             </a:pPr>
             <a:r>
-              <a:t>• Integration with augmented reality and metaverse environments</a:t>
+              <a:t>• High convenience for busy consumers</a:t>
             </a:r>
           </a:p>
           <a:p>
@@ -4344,7 +4313,7 @@
               </a:defRPr>
             </a:pPr>
             <a:r>
-              <a:t>• Micro-gesture recognition for wearable technology</a:t>
+              <a:t>• Expanded market reach for small businesses</a:t>
             </a:r>
           </a:p>
           <a:p>
@@ -4359,7 +4328,7 @@
               </a:defRPr>
             </a:pPr>
             <a:r>
-              <a:t>• Improved AI models for zero-latency response</a:t>
+              <a:t>• Flexible income opportunities for delivery personnel</a:t>
             </a:r>
           </a:p>
           <a:p>
@@ -4374,230 +4343,7 @@
               </a:defRPr>
             </a:pPr>
             <a:r>
-              <a:t>• Seamless multi-modal interaction combining voice and gestures</a:t>
-            </a:r>
-          </a:p>
-        </p:txBody>
-      </p:sp>
-      <p:sp>
-        <p:nvSpPr>
-          <p:cNvPr id="5" name="TextBox 4"/>
-          <p:cNvSpPr txBox="1"/>
-          <p:nvPr/>
-        </p:nvSpPr>
-        <p:spPr>
-          <a:xfrm>
-            <a:off x="640080" y="6400800"/>
-            <a:ext cx="10972800" cy="274320"/>
-          </a:xfrm>
-          <a:prstGeom prst="rect">
-            <a:avLst/>
-          </a:prstGeom>
-          <a:noFill/>
-        </p:spPr>
-        <p:txBody>
-          <a:bodyPr wrap="none">
-            <a:spAutoFit/>
-          </a:bodyPr>
-          <a:lstStyle/>
-          <a:p>
-            <a:pPr>
-              <a:defRPr sz="1000">
-                <a:solidFill>
-                  <a:srgbClr val="2563EB"/>
-                </a:solidFill>
-              </a:defRPr>
-            </a:pPr>
-            <a:r>
-              <a:t>AI PPT Generator • Powered by Gemini AI</a:t>
-            </a:r>
-          </a:p>
-        </p:txBody>
-      </p:sp>
-    </p:spTree>
-  </p:cSld>
-  <p:clrMapOvr>
-    <a:masterClrMapping/>
-  </p:clrMapOvr>
-</p:sld>
-</file>
-
-<file path=ppt/slides/slide7.xml><?xml version="1.0" encoding="utf-8"?>
-<p:sld xmlns:a="http://schemas.openxmlformats.org/drawingml/2006/main" xmlns:p="http://schemas.openxmlformats.org/presentationml/2006/main" xmlns:r="http://schemas.openxmlformats.org/officeDocument/2006/relationships">
-  <p:cSld>
-    <p:bg>
-      <p:bgPr>
-        <a:solidFill>
-          <a:srgbClr val="FFFFFF"/>
-        </a:solidFill>
-        <a:effectLst/>
-      </p:bgPr>
-    </p:bg>
-    <p:spTree>
-      <p:nvGrpSpPr>
-        <p:cNvPr id="1" name=""/>
-        <p:cNvGrpSpPr/>
-        <p:nvPr/>
-      </p:nvGrpSpPr>
-      <p:grpSpPr/>
-      <p:sp>
-        <p:nvSpPr>
-          <p:cNvPr id="2" name="Rectangle 1"/>
-          <p:cNvSpPr/>
-          <p:nvPr/>
-        </p:nvSpPr>
-        <p:spPr>
-          <a:xfrm>
-            <a:off x="0" y="0"/>
-            <a:ext cx="9144000" cy="228600"/>
-          </a:xfrm>
-          <a:prstGeom prst="rect">
-            <a:avLst/>
-          </a:prstGeom>
-          <a:solidFill>
-            <a:srgbClr val="EA580C"/>
-          </a:solidFill>
-          <a:ln>
-            <a:noFill/>
-          </a:ln>
-        </p:spPr>
-        <p:style>
-          <a:lnRef idx="1">
-            <a:schemeClr val="accent1"/>
-          </a:lnRef>
-          <a:fillRef idx="3">
-            <a:schemeClr val="accent1"/>
-          </a:fillRef>
-          <a:effectRef idx="2">
-            <a:schemeClr val="accent1"/>
-          </a:effectRef>
-          <a:fontRef idx="minor">
-            <a:schemeClr val="lt1"/>
-          </a:fontRef>
-        </p:style>
-        <p:txBody>
-          <a:bodyPr rtlCol="0" anchor="ctr"/>
-          <a:lstStyle/>
-          <a:p>
-            <a:pPr algn="ctr"/>
-          </a:p>
-        </p:txBody>
-      </p:sp>
-      <p:sp>
-        <p:nvSpPr>
-          <p:cNvPr id="3" name="TextBox 2"/>
-          <p:cNvSpPr txBox="1"/>
-          <p:nvPr/>
-        </p:nvSpPr>
-        <p:spPr>
-          <a:xfrm>
-            <a:off x="640080" y="548640"/>
-            <a:ext cx="10972800" cy="914400"/>
-          </a:xfrm>
-          <a:prstGeom prst="rect">
-            <a:avLst/>
-          </a:prstGeom>
-          <a:noFill/>
-        </p:spPr>
-        <p:txBody>
-          <a:bodyPr wrap="none">
-            <a:spAutoFit/>
-          </a:bodyPr>
-          <a:lstStyle/>
-          <a:p>
-            <a:pPr>
-              <a:defRPr sz="3000" b="1">
-                <a:solidFill>
-                  <a:srgbClr val="0F172A"/>
-                </a:solidFill>
-              </a:defRPr>
-            </a:pPr>
-            <a:r>
-              <a:t>Conclusion</a:t>
-            </a:r>
-          </a:p>
-        </p:txBody>
-      </p:sp>
-      <p:sp>
-        <p:nvSpPr>
-          <p:cNvPr id="4" name="TextBox 3"/>
-          <p:cNvSpPr txBox="1"/>
-          <p:nvPr/>
-        </p:nvSpPr>
-        <p:spPr>
-          <a:xfrm>
-            <a:off x="822960" y="1645920"/>
-            <a:ext cx="10515600" cy="4389120"/>
-          </a:xfrm>
-          <a:prstGeom prst="rect">
-            <a:avLst/>
-          </a:prstGeom>
-          <a:noFill/>
-        </p:spPr>
-        <p:txBody>
-          <a:bodyPr wrap="none">
-            <a:spAutoFit/>
-          </a:bodyPr>
-          <a:lstStyle/>
-          <a:p/>
-          <a:p>
-            <a:pPr>
-              <a:spcAft>
-                <a:spcPts val="1200"/>
-              </a:spcAft>
-              <a:defRPr sz="2000">
-                <a:solidFill>
-                  <a:srgbClr val="0F172A"/>
-                </a:solidFill>
-              </a:defRPr>
-            </a:pPr>
-            <a:r>
-              <a:t>• Gesture control redefines how we interact with technology</a:t>
-            </a:r>
-          </a:p>
-          <a:p>
-            <a:pPr>
-              <a:spcAft>
-                <a:spcPts val="1200"/>
-              </a:spcAft>
-              <a:defRPr sz="2000">
-                <a:solidFill>
-                  <a:srgbClr val="0F172A"/>
-                </a:solidFill>
-              </a:defRPr>
-            </a:pPr>
-            <a:r>
-              <a:t>• Overcoming hardware and software challenges is ongoing</a:t>
-            </a:r>
-          </a:p>
-          <a:p>
-            <a:pPr>
-              <a:spcAft>
-                <a:spcPts val="1200"/>
-              </a:spcAft>
-              <a:defRPr sz="2000">
-                <a:solidFill>
-                  <a:srgbClr val="0F172A"/>
-                </a:solidFill>
-              </a:defRPr>
-            </a:pPr>
-            <a:r>
-              <a:t>• Poised to become a standard interface in daily life</a:t>
-            </a:r>
-          </a:p>
-          <a:p>
-            <a:pPr>
-              <a:spcAft>
-                <a:spcPts val="1200"/>
-              </a:spcAft>
-              <a:defRPr sz="2000">
-                <a:solidFill>
-                  <a:srgbClr val="0F172A"/>
-                </a:solidFill>
-              </a:defRPr>
-            </a:pPr>
-            <a:r>
-              <a:t>• Opens new possibilities for human-machine synergy</a:t>
+              <a:t>• Data-driven insights for continuous improvement</a:t>
             </a:r>
           </a:p>
         </p:txBody>

</xml_diff>